<commit_message>
Artículo revisado (tablas derechas, 25 referencias, sin apéndice) y enlaces al nombre nuevo del repositorio
</commit_message>
<xml_diff>
--- a/presentacion/Entregable3_sustentacion.pptx
+++ b/presentacion/Entregable3_sustentacion.pptx
@@ -118,7 +118,7 @@
   <p:extLst>
     <p:ext uri="{521415D9-36F7-43E2-AB2F-B90AF26B5E84}">
       <p14:sectionLst xmlns:p14="http://schemas.microsoft.com/office/powerpoint/2010/main">
-        <p14:section name="Datos" id="{7604d61f-fc94-6695-f0b7-4cd5e50e44a9}">
+        <p14:section name="Datos" id="{70c13221-b20e-eee6-dcb7-91fc93e871f7}">
           <p14:sldIdLst>
             <p14:sldId id="256"/>
             <p14:sldId id="257"/>
@@ -126,7 +126,7 @@
             <p14:sldId id="259"/>
           </p14:sldIdLst>
         </p14:section>
-        <p14:section name="Pipeline, optimización, cómputo y evaluación" id="{dc5f182a-03dc-c016-3980-e08606bdcf05}">
+        <p14:section name="Pipeline, optimización, cómputo y evaluación" id="{0cbee07a-3664-18b1-5c29-41125bb86d59}">
           <p14:sldIdLst>
             <p14:sldId id="260"/>
             <p14:sldId id="261"/>
@@ -135,7 +135,7 @@
             <p14:sldId id="264"/>
           </p14:sldIdLst>
         </p14:section>
-        <p14:section name="Modelo nuevo, estadística y conclusiones" id="{775dd04c-29fc-88fb-2ea8-64c176974188}">
+        <p14:section name="Modelo nuevo, estadística y conclusiones" id="{2f3f9be0-0a74-206e-e104-692901a9e3c0}">
           <p14:sldIdLst>
             <p14:sldId id="265"/>
             <p14:sldId id="266"/>
@@ -2833,7 +2833,7 @@
                   <a:schemeClr val="accent5"/>
                 </a:solidFill>
               </a:rPr>
-              <a:t>Libro: rubenesg.github.io/predicci-n-de-fuga-de-clientes-en-fintech</a:t>
+              <a:t>Libro: rubenesg.github.io/Prediccion-de-fuga-de-clientes-en-fintech</a:t>
             </a:r>
             <a:endParaRPr lang="en-US" sz="1000" dirty="0"/>
           </a:p>
@@ -4996,7 +4996,7 @@
                   <a:schemeClr val="bg1"/>
                 </a:solidFill>
               </a:rPr>
-              <a:t>Libro, código, cuadernos ejecutados y resultados: github.com/RubenEsg/predicci-n-de-fuga-de-clientes-en-fintech</a:t>
+              <a:t>Libro, código, cuadernos ejecutados y resultados: github.com/RubenEsg/Prediccion-de-fuga-de-clientes-en-fintech</a:t>
             </a:r>
             <a:endParaRPr lang="en-US" sz="1200" dirty="0"/>
           </a:p>

</xml_diff>